<commit_message>
-updated APCSA lecture slides
</commit_message>
<xml_diff>
--- a/files/APCSA/Unit2.pptx
+++ b/files/APCSA/Unit2.pptx
@@ -230,7 +230,7 @@
           <a:p>
             <a:fld id="{6D4F71AE-FACE-4DB9-B871-AC14F33069FF}" type="datetimeFigureOut">
               <a:rPr lang="zh-CN" altLang="en-US" smtClean="0"/>
-              <a:t>2025/10/10</a:t>
+              <a:t>2025/10/13</a:t>
             </a:fld>
             <a:endParaRPr lang="zh-CN" altLang="en-US"/>
           </a:p>
@@ -1369,7 +1369,7 @@
           <a:p>
             <a:fld id="{4122E7CC-E1EA-4EDB-A11B-9EBE68CA3B7D}" type="datetimeFigureOut">
               <a:rPr lang="zh-CN" altLang="en-US" smtClean="0"/>
-              <a:t>2025/10/10</a:t>
+              <a:t>2025/10/13</a:t>
             </a:fld>
             <a:endParaRPr lang="zh-CN" altLang="en-US"/>
           </a:p>
@@ -1569,7 +1569,7 @@
           <a:p>
             <a:fld id="{4122E7CC-E1EA-4EDB-A11B-9EBE68CA3B7D}" type="datetimeFigureOut">
               <a:rPr lang="zh-CN" altLang="en-US" smtClean="0"/>
-              <a:t>2025/10/10</a:t>
+              <a:t>2025/10/13</a:t>
             </a:fld>
             <a:endParaRPr lang="zh-CN" altLang="en-US"/>
           </a:p>
@@ -1779,7 +1779,7 @@
           <a:p>
             <a:fld id="{4122E7CC-E1EA-4EDB-A11B-9EBE68CA3B7D}" type="datetimeFigureOut">
               <a:rPr lang="zh-CN" altLang="en-US" smtClean="0"/>
-              <a:t>2025/10/10</a:t>
+              <a:t>2025/10/13</a:t>
             </a:fld>
             <a:endParaRPr lang="zh-CN" altLang="en-US"/>
           </a:p>
@@ -1979,7 +1979,7 @@
           <a:p>
             <a:fld id="{4122E7CC-E1EA-4EDB-A11B-9EBE68CA3B7D}" type="datetimeFigureOut">
               <a:rPr lang="zh-CN" altLang="en-US" smtClean="0"/>
-              <a:t>2025/10/10</a:t>
+              <a:t>2025/10/13</a:t>
             </a:fld>
             <a:endParaRPr lang="zh-CN" altLang="en-US"/>
           </a:p>
@@ -2255,7 +2255,7 @@
           <a:p>
             <a:fld id="{4122E7CC-E1EA-4EDB-A11B-9EBE68CA3B7D}" type="datetimeFigureOut">
               <a:rPr lang="zh-CN" altLang="en-US" smtClean="0"/>
-              <a:t>2025/10/10</a:t>
+              <a:t>2025/10/13</a:t>
             </a:fld>
             <a:endParaRPr lang="zh-CN" altLang="en-US"/>
           </a:p>
@@ -2523,7 +2523,7 @@
           <a:p>
             <a:fld id="{4122E7CC-E1EA-4EDB-A11B-9EBE68CA3B7D}" type="datetimeFigureOut">
               <a:rPr lang="zh-CN" altLang="en-US" smtClean="0"/>
-              <a:t>2025/10/10</a:t>
+              <a:t>2025/10/13</a:t>
             </a:fld>
             <a:endParaRPr lang="zh-CN" altLang="en-US"/>
           </a:p>
@@ -2938,7 +2938,7 @@
           <a:p>
             <a:fld id="{4122E7CC-E1EA-4EDB-A11B-9EBE68CA3B7D}" type="datetimeFigureOut">
               <a:rPr lang="zh-CN" altLang="en-US" smtClean="0"/>
-              <a:t>2025/10/10</a:t>
+              <a:t>2025/10/13</a:t>
             </a:fld>
             <a:endParaRPr lang="zh-CN" altLang="en-US"/>
           </a:p>
@@ -3080,7 +3080,7 @@
           <a:p>
             <a:fld id="{4122E7CC-E1EA-4EDB-A11B-9EBE68CA3B7D}" type="datetimeFigureOut">
               <a:rPr lang="zh-CN" altLang="en-US" smtClean="0"/>
-              <a:t>2025/10/10</a:t>
+              <a:t>2025/10/13</a:t>
             </a:fld>
             <a:endParaRPr lang="zh-CN" altLang="en-US"/>
           </a:p>
@@ -3193,7 +3193,7 @@
           <a:p>
             <a:fld id="{4122E7CC-E1EA-4EDB-A11B-9EBE68CA3B7D}" type="datetimeFigureOut">
               <a:rPr lang="zh-CN" altLang="en-US" smtClean="0"/>
-              <a:t>2025/10/10</a:t>
+              <a:t>2025/10/13</a:t>
             </a:fld>
             <a:endParaRPr lang="zh-CN" altLang="en-US"/>
           </a:p>
@@ -3506,7 +3506,7 @@
           <a:p>
             <a:fld id="{4122E7CC-E1EA-4EDB-A11B-9EBE68CA3B7D}" type="datetimeFigureOut">
               <a:rPr lang="zh-CN" altLang="en-US" smtClean="0"/>
-              <a:t>2025/10/10</a:t>
+              <a:t>2025/10/13</a:t>
             </a:fld>
             <a:endParaRPr lang="zh-CN" altLang="en-US"/>
           </a:p>
@@ -3795,7 +3795,7 @@
           <a:p>
             <a:fld id="{4122E7CC-E1EA-4EDB-A11B-9EBE68CA3B7D}" type="datetimeFigureOut">
               <a:rPr lang="zh-CN" altLang="en-US" smtClean="0"/>
-              <a:t>2025/10/10</a:t>
+              <a:t>2025/10/13</a:t>
             </a:fld>
             <a:endParaRPr lang="zh-CN" altLang="en-US"/>
           </a:p>
@@ -4038,7 +4038,7 @@
           <a:p>
             <a:fld id="{4122E7CC-E1EA-4EDB-A11B-9EBE68CA3B7D}" type="datetimeFigureOut">
               <a:rPr lang="zh-CN" altLang="en-US" smtClean="0"/>
-              <a:t>2025/10/10</a:t>
+              <a:t>2025/10/13</a:t>
             </a:fld>
             <a:endParaRPr lang="zh-CN" altLang="en-US"/>
           </a:p>

</xml_diff>